<commit_message>
Team leader Anushka Tomar; both members IMB9 at SDA Bocconi Asia Center
Co-authored-by: Anushka Tomar <343368741+anushkatomar1008-boop@users.noreply.github.com>
</commit_message>
<xml_diff>
--- a/docs/BreatheTwin_presentation.pptx
+++ b/docs/BreatheTwin_presentation.pptx
@@ -5652,7 +5652,7 @@
       </p:sp>
       <p:sp>
         <p:nvSpPr>
-          <p:cNvPr id="9" name="Avatar Yash Saxena"/>
+          <p:cNvPr id="9" name="Avatar Anushka Tomar"/>
           <p:cNvSpPr/>
           <p:nvPr/>
         </p:nvSpPr>
@@ -5700,21 +5700,21 @@
                 </a:solidFill>
                 <a:latin typeface="Times New Roman"/>
               </a:rPr>
-              <a:t>YS</a:t>
-            </a:r>
-          </a:p>
-        </p:txBody>
-      </p:sp>
-      <p:sp>
-        <p:nvSpPr>
-          <p:cNvPr id="10" name="Name Yash Saxena"/>
+              <a:t>AT</a:t>
+            </a:r>
+          </a:p>
+        </p:txBody>
+      </p:sp>
+      <p:sp>
+        <p:nvSpPr>
+          <p:cNvPr id="10" name="Name Anushka Tomar"/>
           <p:cNvSpPr txBox="1"/>
           <p:nvPr/>
         </p:nvSpPr>
         <p:spPr>
           <a:xfrm>
             <a:off x="3886200" y="5212080"/>
-            <a:ext cx="2331720" cy="365760"/>
+            <a:ext cx="2331720" cy="640080"/>
           </a:xfrm>
           <a:prstGeom prst="rect">
             <a:avLst/>
@@ -5729,7 +5729,7 @@
           <a:p>
             <a:pPr algn="ctr">
               <a:spcAft>
-                <a:spcPts val="300"/>
+                <a:spcPts val="0"/>
               </a:spcAft>
               <a:buNone/>
             </a:pPr>
@@ -5740,14 +5740,31 @@
                 </a:solidFill>
                 <a:latin typeface="Times New Roman"/>
               </a:rPr>
-              <a:t>Yash Saxena</a:t>
-            </a:r>
-          </a:p>
-        </p:txBody>
-      </p:sp>
-      <p:sp>
-        <p:nvSpPr>
-          <p:cNvPr id="11" name="Avatar Anushka Tomar"/>
+              <a:t>Anushka Tomar</a:t>
+            </a:r>
+          </a:p>
+          <a:p>
+            <a:pPr algn="ctr">
+              <a:spcAft>
+                <a:spcPts val="0"/>
+              </a:spcAft>
+              <a:buNone/>
+            </a:pPr>
+            <a:r>
+              <a:rPr sz="1800" b="0" i="1">
+                <a:solidFill>
+                  <a:srgbClr val="111111"/>
+                </a:solidFill>
+                <a:latin typeface="Times New Roman"/>
+              </a:rPr>
+              <a:t>Team leader</a:t>
+            </a:r>
+          </a:p>
+        </p:txBody>
+      </p:sp>
+      <p:sp>
+        <p:nvSpPr>
+          <p:cNvPr id="11" name="Avatar Yash Saxena"/>
           <p:cNvSpPr/>
           <p:nvPr/>
         </p:nvSpPr>
@@ -5795,21 +5812,21 @@
                 </a:solidFill>
                 <a:latin typeface="Times New Roman"/>
               </a:rPr>
-              <a:t>AT</a:t>
-            </a:r>
-          </a:p>
-        </p:txBody>
-      </p:sp>
-      <p:sp>
-        <p:nvSpPr>
-          <p:cNvPr id="12" name="Name Anushka Tomar"/>
+              <a:t>YS</a:t>
+            </a:r>
+          </a:p>
+        </p:txBody>
+      </p:sp>
+      <p:sp>
+        <p:nvSpPr>
+          <p:cNvPr id="12" name="Name Yash Saxena"/>
           <p:cNvSpPr txBox="1"/>
           <p:nvPr/>
         </p:nvSpPr>
         <p:spPr>
           <a:xfrm>
             <a:off x="6172200" y="5212080"/>
-            <a:ext cx="2331720" cy="365760"/>
+            <a:ext cx="2331720" cy="640080"/>
           </a:xfrm>
           <a:prstGeom prst="rect">
             <a:avLst/>
@@ -5824,7 +5841,7 @@
           <a:p>
             <a:pPr algn="ctr">
               <a:spcAft>
-                <a:spcPts val="300"/>
+                <a:spcPts val="0"/>
               </a:spcAft>
               <a:buNone/>
             </a:pPr>
@@ -5835,7 +5852,7 @@
                 </a:solidFill>
                 <a:latin typeface="Times New Roman"/>
               </a:rPr>
-              <a:t>Anushka Tomar</a:t>
+              <a:t>Yash Saxena</a:t>
             </a:r>
           </a:p>
         </p:txBody>
@@ -11216,7 +11233,7 @@
                 </a:solidFill>
                 <a:latin typeface="Times New Roman"/>
               </a:rPr>
-              <a:t>Yash Saxena · Anushka Tomar</a:t>
+              <a:t>Anushka Tomar (Team leader) · Yash Saxena</a:t>
             </a:r>
           </a:p>
           <a:p>

</xml_diff>

<commit_message>
Deck: stress-test slide now reports the SpO2 safety override as fixed
Co-Authored-By: Claude Opus 5.5 <noreply@anthropic.com>
Claude-Session: https://claude.ai/code/session_011bygegPWEFyMw8vnEFPYeY
</commit_message>
<xml_diff>
--- a/docs/BreatheTwin_presentation.pptx
+++ b/docs/BreatheTwin_presentation.pptx
@@ -9419,7 +9419,7 @@
                 </a:solidFill>
                 <a:latin typeface="Times New Roman"/>
               </a:rPr>
-              <a:t>To fix: </a:t>
+              <a:t>Fixed: </a:t>
             </a:r>
             <a:r>
               <a:rPr sz="1150">
@@ -9428,7 +9428,7 @@
                 </a:solidFill>
                 <a:latin typeface="Times New Roman"/>
               </a:rPr>
-              <a:t>an SpO2 drop alone barely moves the learned risk (the rule layer still flags it urgent).</a:t>
+              <a:t>oxygen at 82% scored Low, so a safety override now makes any reading below 90% Urgent.</a:t>
             </a:r>
           </a:p>
           <a:p>

</xml_diff>